<commit_message>
feat: scan original PPT font families (Tahoma, Verdana, Roboto, Lucida Sans Unicode, Arial Black) and apply exact style preserving edit
</commit_message>
<xml_diff>
--- a/Investors Pitch Deck (Optimized).pptx
+++ b/Investors Pitch Deck (Optimized).pptx
@@ -4476,7 +4476,7 @@
           </a:solidFill>
         </p:spPr>
         <p:txBody>
-          <a:bodyPr wrap="square" lIns="73152" tIns="54864" rIns="73152" bIns="54864" rtlCol="0"/>
+          <a:bodyPr wrap="square" lIns="0" tIns="0" rIns="0" bIns="0" rtlCol="0"/>
           <a:lstStyle/>
           <a:p>
             <a:endParaRPr dirty="0"/>
@@ -9095,7 +9095,7 @@
           </a:prstGeom>
         </p:spPr>
         <p:txBody>
-          <a:bodyPr vert="horz" wrap="square" lIns="73152" tIns="54864" rIns="73152" bIns="54864" rtlCol="0">
+          <a:bodyPr vert="horz" wrap="square" lIns="0" tIns="12700" rIns="0" bIns="0" rtlCol="0">
             <a:spAutoFit/>
           </a:bodyPr>
           <a:lstStyle/>
@@ -9107,7 +9107,6 @@
               <a:spcBef>
                 <a:spcPts val="100"/>
               </a:spcBef>
-              <a:defRPr/>
             </a:pPr>
             <a:r>
               <a:rPr sz="5000" spc="-615" dirty="0">
@@ -9142,7 +9141,7 @@
           </a:prstGeom>
         </p:spPr>
         <p:txBody>
-          <a:bodyPr vert="horz" wrap="square" lIns="73152" tIns="54864" rIns="73152" bIns="54864" rtlCol="0">
+          <a:bodyPr vert="horz" wrap="square" lIns="0" tIns="12700" rIns="0" bIns="0" rtlCol="0">
             <a:spAutoFit/>
           </a:bodyPr>
           <a:lstStyle/>
@@ -9154,7 +9153,6 @@
               <a:spcBef>
                 <a:spcPts val="100"/>
               </a:spcBef>
-              <a:defRPr/>
             </a:pPr>
             <a:r>
               <a:rPr sz="5000" spc="-114" dirty="0">
@@ -9189,7 +9187,7 @@
           </a:prstGeom>
         </p:spPr>
         <p:txBody>
-          <a:bodyPr vert="horz" wrap="square" lIns="73152" tIns="54864" rIns="73152" bIns="54864" rtlCol="0">
+          <a:bodyPr vert="horz" wrap="square" lIns="0" tIns="17145" rIns="0" bIns="0" rtlCol="0">
             <a:spAutoFit/>
           </a:bodyPr>
           <a:lstStyle/>
@@ -9201,7 +9199,6 @@
               <a:spcBef>
                 <a:spcPts val="135"/>
               </a:spcBef>
-              <a:defRPr/>
             </a:pPr>
             <a:r>
               <a:rPr sz="3100" b="1" spc="114" dirty="0">
@@ -9286,7 +9283,7 @@
           </a:prstGeom>
         </p:spPr>
         <p:txBody>
-          <a:bodyPr vert="horz" wrap="square" lIns="73152" tIns="54864" rIns="73152" bIns="54864" rtlCol="0">
+          <a:bodyPr vert="horz" wrap="square" lIns="0" tIns="22860" rIns="0" bIns="0" rtlCol="0">
             <a:spAutoFit/>
           </a:bodyPr>
           <a:lstStyle/>
@@ -9298,11 +9295,11 @@
               <a:spcBef>
                 <a:spcPts val="180"/>
               </a:spcBef>
-              <a:spcAft>
-                <a:spcPts val="400"/>
-              </a:spcAft>
-              <a:defRPr sz="1400" b="1">
-                <a:latin typeface="Arial"/>
+              <a:defRPr sz="7500">
+                <a:solidFill>
+                  <a:srgbClr val="122358"/>
+                </a:solidFill>
+                <a:latin typeface="Arial Black"/>
               </a:defRPr>
             </a:pPr>
             <a:r>
@@ -9315,11 +9312,11 @@
           </a:p>
           <a:p>
             <a:pPr>
-              <a:spcBef>
-                <a:spcPts val="200"/>
-              </a:spcBef>
-              <a:defRPr sz="1200">
-                <a:latin typeface="Arial"/>
+              <a:defRPr sz="7500">
+                <a:solidFill>
+                  <a:srgbClr val="122358"/>
+                </a:solidFill>
+                <a:latin typeface="Arial Black"/>
               </a:defRPr>
             </a:pPr>
             <a:r>
@@ -9344,7 +9341,7 @@
           </a:prstGeom>
         </p:spPr>
         <p:txBody>
-          <a:bodyPr vert="horz" wrap="square" lIns="73152" tIns="54864" rIns="73152" bIns="54864" rtlCol="0">
+          <a:bodyPr vert="horz" wrap="square" lIns="0" tIns="12065" rIns="0" bIns="0" rtlCol="0">
             <a:spAutoFit/>
           </a:bodyPr>
           <a:lstStyle/>
@@ -9356,11 +9353,11 @@
               <a:spcBef>
                 <a:spcPts val="95"/>
               </a:spcBef>
-              <a:spcAft>
-                <a:spcPts val="400"/>
-              </a:spcAft>
-              <a:defRPr sz="1400" b="1">
-                <a:latin typeface="Arial"/>
+              <a:defRPr sz="2750">
+                <a:solidFill>
+                  <a:srgbClr val="122358"/>
+                </a:solidFill>
+                <a:latin typeface="Tahoma"/>
               </a:defRPr>
             </a:pPr>
             <a:r>
@@ -9373,11 +9370,11 @@
           </a:p>
           <a:p>
             <a:pPr>
-              <a:spcBef>
-                <a:spcPts val="200"/>
-              </a:spcBef>
-              <a:defRPr sz="1200">
-                <a:latin typeface="Arial"/>
+              <a:defRPr sz="2750">
+                <a:solidFill>
+                  <a:srgbClr val="122358"/>
+                </a:solidFill>
+                <a:latin typeface="Tahoma"/>
               </a:defRPr>
             </a:pPr>
             <a:r>
@@ -9402,7 +9399,7 @@
           </a:prstGeom>
         </p:spPr>
         <p:txBody>
-          <a:bodyPr vert="horz" wrap="square" lIns="73152" tIns="54864" rIns="73152" bIns="54864" rtlCol="0">
+          <a:bodyPr vert="horz" wrap="square" lIns="0" tIns="12700" rIns="0" bIns="0" rtlCol="0">
             <a:spAutoFit/>
           </a:bodyPr>
           <a:lstStyle/>
@@ -9414,11 +9411,11 @@
               <a:spcBef>
                 <a:spcPts val="100"/>
               </a:spcBef>
-              <a:spcAft>
-                <a:spcPts val="400"/>
-              </a:spcAft>
-              <a:defRPr sz="1400" b="1">
-                <a:latin typeface="Arial"/>
+              <a:defRPr sz="7500">
+                <a:solidFill>
+                  <a:srgbClr val="122358"/>
+                </a:solidFill>
+                <a:latin typeface="Arial Black"/>
               </a:defRPr>
             </a:pPr>
             <a:r>
@@ -9437,8 +9434,11 @@
               <a:spcBef>
                 <a:spcPts val="2990"/>
               </a:spcBef>
-              <a:defRPr sz="1300">
-                <a:latin typeface="Arial"/>
+              <a:defRPr sz="7500">
+                <a:solidFill>
+                  <a:srgbClr val="122358"/>
+                </a:solidFill>
+                <a:latin typeface="Arial Black"/>
               </a:defRPr>
             </a:pPr>
             <a:r>
@@ -9485,7 +9485,7 @@
           </a:prstGeom>
         </p:spPr>
         <p:txBody>
-          <a:bodyPr vert="horz" wrap="square" lIns="73152" tIns="54864" rIns="73152" bIns="54864" rtlCol="0">
+          <a:bodyPr vert="horz" wrap="square" lIns="0" tIns="17145" rIns="0" bIns="0" rtlCol="0">
             <a:spAutoFit/>
           </a:bodyPr>
           <a:lstStyle/>
@@ -9497,7 +9497,6 @@
               <a:spcBef>
                 <a:spcPts val="135"/>
               </a:spcBef>
-              <a:defRPr/>
             </a:pPr>
             <a:r>
               <a:rPr sz="4150" spc="105" dirty="0">
@@ -9550,14 +9549,14 @@
           <a:noFill/>
         </p:spPr>
         <p:txBody>
-          <a:bodyPr wrap="square" rtlCol="0" lIns="73152" rIns="73152" tIns="54864" bIns="54864">
+          <a:bodyPr wrap="square" rtlCol="0">
             <a:spAutoFit/>
           </a:bodyPr>
           <a:lstStyle/>
           <a:p>
             <a:pPr>
-              <a:defRPr sz="1300" b="1">
-                <a:latin typeface="Arial"/>
+              <a:defRPr sz="4000">
+                <a:solidFill/>
               </a:defRPr>
             </a:pPr>
             <a:r>
@@ -9635,7 +9634,7 @@
           </a:solidFill>
         </p:spPr>
         <p:txBody>
-          <a:bodyPr wrap="square" lIns="73152" tIns="54864" rIns="73152" bIns="54864" rtlCol="0"/>
+          <a:bodyPr wrap="square" lIns="0" tIns="0" rIns="0" bIns="0" rtlCol="0"/>
           <a:lstStyle/>
           <a:p>
             <a:endParaRPr/>
@@ -9685,7 +9684,7 @@
           </a:solidFill>
         </p:spPr>
         <p:txBody>
-          <a:bodyPr wrap="square" lIns="73152" tIns="54864" rIns="73152" bIns="54864" rtlCol="0"/>
+          <a:bodyPr wrap="square" lIns="0" tIns="0" rIns="0" bIns="0" rtlCol="0"/>
           <a:lstStyle/>
           <a:p>
             <a:endParaRPr/>
@@ -10044,7 +10043,7 @@
           </a:prstGeom>
         </p:spPr>
         <p:txBody>
-          <a:bodyPr vert="horz" wrap="square" lIns="73152" tIns="54864" rIns="73152" bIns="54864" rtlCol="0">
+          <a:bodyPr vert="horz" wrap="square" lIns="0" tIns="12700" rIns="0" bIns="0" rtlCol="0">
             <a:spAutoFit/>
           </a:bodyPr>
           <a:lstStyle/>
@@ -10056,11 +10055,9 @@
               <a:spcBef>
                 <a:spcPts val="100"/>
               </a:spcBef>
-              <a:spcAft>
-                <a:spcPts val="400"/>
-              </a:spcAft>
-              <a:defRPr sz="1400" b="1">
-                <a:latin typeface="Arial"/>
+              <a:defRPr sz="1800">
+                <a:solidFill/>
+                <a:latin typeface="Tahoma"/>
               </a:defRPr>
             </a:pPr>
             <a:r>
@@ -10076,11 +10073,8 @@
               <a:lnSpc>
                 <a:spcPct val="107600"/>
               </a:lnSpc>
-              <a:spcBef>
-                <a:spcPts val="200"/>
-              </a:spcBef>
-              <a:defRPr sz="1200">
-                <a:latin typeface="Arial"/>
+              <a:defRPr sz="1800">
+                <a:latin typeface="Tahoma"/>
               </a:defRPr>
             </a:pPr>
             <a:r>
@@ -10548,7 +10542,7 @@
           </a:prstGeom>
         </p:spPr>
         <p:txBody>
-          <a:bodyPr vert="horz" wrap="square" lIns="73152" tIns="54864" rIns="73152" bIns="54864" rtlCol="0">
+          <a:bodyPr vert="horz" wrap="square" lIns="0" tIns="12700" rIns="0" bIns="0" rtlCol="0">
             <a:spAutoFit/>
           </a:bodyPr>
           <a:lstStyle/>
@@ -10560,11 +10554,9 @@
               <a:spcBef>
                 <a:spcPts val="100"/>
               </a:spcBef>
-              <a:spcAft>
-                <a:spcPts val="400"/>
-              </a:spcAft>
-              <a:defRPr sz="1400" b="1">
-                <a:latin typeface="Arial"/>
+              <a:defRPr sz="1800">
+                <a:solidFill/>
+                <a:latin typeface="Tahoma"/>
               </a:defRPr>
             </a:pPr>
             <a:r>
@@ -10577,11 +10569,8 @@
           </a:p>
           <a:p>
             <a:pPr>
-              <a:spcBef>
-                <a:spcPts val="200"/>
-              </a:spcBef>
-              <a:defRPr sz="1200">
-                <a:latin typeface="Arial"/>
+              <a:defRPr sz="1800">
+                <a:latin typeface="Tahoma"/>
               </a:defRPr>
             </a:pPr>
             <a:r>
@@ -11610,7 +11599,7 @@
           </a:prstGeom>
         </p:spPr>
         <p:txBody>
-          <a:bodyPr vert="horz" wrap="square" lIns="73152" tIns="54864" rIns="73152" bIns="54864" rtlCol="0">
+          <a:bodyPr vert="horz" wrap="square" lIns="0" tIns="16510" rIns="0" bIns="0" rtlCol="0">
             <a:spAutoFit/>
           </a:bodyPr>
           <a:lstStyle/>
@@ -11622,11 +11611,9 @@
               <a:spcBef>
                 <a:spcPts val="130"/>
               </a:spcBef>
-              <a:spcAft>
-                <a:spcPts val="400"/>
-              </a:spcAft>
-              <a:defRPr sz="1400" b="1">
-                <a:latin typeface="Arial"/>
+              <a:defRPr sz="1800">
+                <a:solidFill/>
+                <a:latin typeface="Tahoma"/>
               </a:defRPr>
             </a:pPr>
             <a:r>
@@ -11643,10 +11630,10 @@
                 <a:spcPct val="107600"/>
               </a:lnSpc>
               <a:spcBef>
-                <a:spcPts val="200"/>
+                <a:spcPts val="5"/>
               </a:spcBef>
-              <a:defRPr sz="1200">
-                <a:latin typeface="Arial"/>
+              <a:defRPr sz="1800">
+                <a:latin typeface="Tahoma"/>
               </a:defRPr>
             </a:pPr>
             <a:r>
@@ -11675,7 +11662,7 @@
           </a:prstGeom>
         </p:spPr>
         <p:txBody>
-          <a:bodyPr vert="horz" wrap="square" lIns="73152" tIns="54864" rIns="73152" bIns="54864" rtlCol="0">
+          <a:bodyPr vert="horz" wrap="square" lIns="0" tIns="2540" rIns="0" bIns="0" rtlCol="0">
             <a:spAutoFit/>
           </a:bodyPr>
           <a:lstStyle/>
@@ -11687,11 +11674,9 @@
               <a:spcBef>
                 <a:spcPts val="20"/>
               </a:spcBef>
-              <a:spcAft>
-                <a:spcPts val="400"/>
-              </a:spcAft>
-              <a:defRPr sz="1400" b="1">
-                <a:latin typeface="Arial"/>
+              <a:defRPr sz="1800">
+                <a:solidFill/>
+                <a:latin typeface="Tahoma"/>
               </a:defRPr>
             </a:pPr>
             <a:r>
@@ -11708,10 +11693,10 @@
                 <a:spcPct val="107600"/>
               </a:lnSpc>
               <a:spcBef>
-                <a:spcPts val="200"/>
+                <a:spcPts val="5"/>
               </a:spcBef>
-              <a:defRPr sz="1200">
-                <a:latin typeface="Arial"/>
+              <a:defRPr sz="1800">
+                <a:latin typeface="Tahoma"/>
               </a:defRPr>
             </a:pPr>
             <a:r>
@@ -11762,7 +11747,7 @@
           </a:prstGeom>
         </p:spPr>
         <p:txBody>
-          <a:bodyPr vert="horz" wrap="square" lIns="73152" tIns="54864" rIns="73152" bIns="54864" rtlCol="0">
+          <a:bodyPr vert="horz" wrap="square" lIns="0" tIns="780415" rIns="0" bIns="0" rtlCol="0">
             <a:spAutoFit/>
           </a:bodyPr>
           <a:lstStyle/>
@@ -11774,11 +11759,8 @@
               <a:spcBef>
                 <a:spcPts val="6145"/>
               </a:spcBef>
-              <a:spcAft>
-                <a:spcPts val="400"/>
-              </a:spcAft>
-              <a:defRPr sz="1400" b="1">
-                <a:latin typeface="Arial"/>
+              <a:defRPr sz="8500">
+                <a:solidFill/>
               </a:defRPr>
             </a:pPr>
             <a:r>
@@ -11792,11 +11774,9 @@
                 <a:spcPct val="100000"/>
               </a:lnSpc>
               <a:spcBef>
-                <a:spcPts val="200"/>
+                <a:spcPts val="1970"/>
               </a:spcBef>
-              <a:defRPr sz="1200">
-                <a:latin typeface="Arial"/>
-              </a:defRPr>
+              <a:defRPr sz="8500"/>
             </a:pPr>
             <a:r>
               <a:t>Where Biomedical Literature Intelligence Meets Knowledge Graphs</a:t>
@@ -11876,7 +11856,7 @@
           </a:solidFill>
         </p:spPr>
         <p:txBody>
-          <a:bodyPr wrap="square" lIns="73152" tIns="54864" rIns="73152" bIns="54864" rtlCol="0"/>
+          <a:bodyPr wrap="square" lIns="0" tIns="0" rIns="0" bIns="0" rtlCol="0"/>
           <a:lstStyle/>
           <a:p>
             <a:endParaRPr/>
@@ -11929,7 +11909,7 @@
           </a:solidFill>
         </p:spPr>
         <p:txBody>
-          <a:bodyPr wrap="square" lIns="73152" tIns="54864" rIns="73152" bIns="54864" rtlCol="0"/>
+          <a:bodyPr wrap="square" lIns="0" tIns="0" rIns="0" bIns="0" rtlCol="0"/>
           <a:lstStyle/>
           <a:p>
             <a:endParaRPr/>
@@ -11988,7 +11968,7 @@
           </a:solidFill>
         </p:spPr>
         <p:txBody>
-          <a:bodyPr wrap="square" lIns="73152" tIns="54864" rIns="73152" bIns="54864" rtlCol="0"/>
+          <a:bodyPr wrap="square" lIns="0" tIns="0" rIns="0" bIns="0" rtlCol="0"/>
           <a:lstStyle/>
           <a:p>
             <a:endParaRPr/>
@@ -12047,7 +12027,7 @@
           </a:solidFill>
         </p:spPr>
         <p:txBody>
-          <a:bodyPr wrap="square" lIns="73152" tIns="54864" rIns="73152" bIns="54864" rtlCol="0"/>
+          <a:bodyPr wrap="square" lIns="0" tIns="0" rIns="0" bIns="0" rtlCol="0"/>
           <a:lstStyle/>
           <a:p>
             <a:endParaRPr/>
@@ -12237,7 +12217,7 @@
           </a:solidFill>
         </p:spPr>
         <p:txBody>
-          <a:bodyPr wrap="square" lIns="73152" tIns="54864" rIns="73152" bIns="54864" rtlCol="0"/>
+          <a:bodyPr wrap="square" lIns="0" tIns="0" rIns="0" bIns="0" rtlCol="0"/>
           <a:lstStyle/>
           <a:p>
             <a:endParaRPr/>
@@ -12260,7 +12240,7 @@
           </a:prstGeom>
         </p:spPr>
         <p:txBody>
-          <a:bodyPr vert="horz" wrap="square" lIns="73152" tIns="54864" rIns="73152" bIns="54864" rtlCol="0">
+          <a:bodyPr vert="horz" wrap="square" lIns="0" tIns="12700" rIns="0" bIns="0" rtlCol="0">
             <a:spAutoFit/>
           </a:bodyPr>
           <a:lstStyle/>
@@ -12272,7 +12252,6 @@
               <a:spcBef>
                 <a:spcPts val="100"/>
               </a:spcBef>
-              <a:defRPr/>
             </a:pPr>
             <a:r>
               <a:rPr sz="1800" b="1" spc="-165" dirty="0">
@@ -12579,7 +12558,7 @@
           </a:prstGeom>
         </p:spPr>
         <p:txBody>
-          <a:bodyPr vert="horz" wrap="square" lIns="73152" tIns="54864" rIns="73152" bIns="54864" rtlCol="0">
+          <a:bodyPr vert="horz" wrap="square" lIns="0" tIns="12700" rIns="0" bIns="0" rtlCol="0">
             <a:spAutoFit/>
           </a:bodyPr>
           <a:lstStyle/>
@@ -12591,7 +12570,6 @@
               <a:spcBef>
                 <a:spcPts val="100"/>
               </a:spcBef>
-              <a:defRPr/>
             </a:pPr>
             <a:r>
               <a:rPr sz="1800" b="1" spc="-25" dirty="0">
@@ -12873,7 +12851,7 @@
           </a:prstGeom>
         </p:spPr>
         <p:txBody>
-          <a:bodyPr vert="horz" wrap="square" lIns="73152" tIns="54864" rIns="73152" bIns="54864" rtlCol="0">
+          <a:bodyPr vert="horz" wrap="square" lIns="0" tIns="12700" rIns="0" bIns="0" rtlCol="0">
             <a:spAutoFit/>
           </a:bodyPr>
           <a:lstStyle/>
@@ -12885,7 +12863,6 @@
               <a:spcBef>
                 <a:spcPts val="100"/>
               </a:spcBef>
-              <a:defRPr/>
             </a:pPr>
             <a:r>
               <a:rPr sz="1800" b="1" spc="-25" dirty="0">
@@ -13875,7 +13852,7 @@
           </a:solidFill>
         </p:spPr>
         <p:txBody>
-          <a:bodyPr wrap="square" lIns="73152" tIns="54864" rIns="73152" bIns="54864" rtlCol="0"/>
+          <a:bodyPr wrap="square" lIns="0" tIns="0" rIns="0" bIns="0" rtlCol="0"/>
           <a:lstStyle/>
           <a:p>
             <a:endParaRPr/>
@@ -13920,7 +13897,7 @@
           </a:prstGeom>
         </p:spPr>
         <p:txBody>
-          <a:bodyPr vert="horz" wrap="square" lIns="73152" tIns="54864" rIns="73152" bIns="54864" rtlCol="0">
+          <a:bodyPr vert="horz" wrap="square" lIns="0" tIns="12700" rIns="0" bIns="0" rtlCol="0">
             <a:spAutoFit/>
           </a:bodyPr>
           <a:lstStyle/>
@@ -13932,7 +13909,6 @@
               <a:spcBef>
                 <a:spcPts val="100"/>
               </a:spcBef>
-              <a:defRPr/>
             </a:pPr>
             <a:r>
               <a:rPr sz="2100" spc="-30" dirty="0">
@@ -13997,7 +13973,7 @@
           </a:prstGeom>
         </p:spPr>
         <p:txBody>
-          <a:bodyPr vert="horz" wrap="square" lIns="73152" tIns="54864" rIns="73152" bIns="54864" rtlCol="0">
+          <a:bodyPr vert="horz" wrap="square" lIns="0" tIns="12700" rIns="0" bIns="0" rtlCol="0">
             <a:spAutoFit/>
           </a:bodyPr>
           <a:lstStyle/>
@@ -14009,7 +13985,6 @@
               <a:spcBef>
                 <a:spcPts val="100"/>
               </a:spcBef>
-              <a:defRPr/>
             </a:pPr>
             <a:r>
               <a:rPr sz="2100" b="1" spc="50" dirty="0">
@@ -14069,7 +14044,7 @@
           </a:prstGeom>
         </p:spPr>
         <p:txBody>
-          <a:bodyPr vert="horz" wrap="square" lIns="73152" tIns="54864" rIns="73152" bIns="54864" rtlCol="0">
+          <a:bodyPr vert="horz" wrap="square" lIns="0" tIns="12700" rIns="0" bIns="0" rtlCol="0">
             <a:spAutoFit/>
           </a:bodyPr>
           <a:lstStyle/>
@@ -14081,7 +14056,6 @@
               <a:spcBef>
                 <a:spcPts val="100"/>
               </a:spcBef>
-              <a:defRPr/>
             </a:pPr>
             <a:r>
               <a:rPr sz="2100" b="1" spc="50" dirty="0">
@@ -14141,7 +14115,7 @@
           </a:prstGeom>
         </p:spPr>
         <p:txBody>
-          <a:bodyPr vert="horz" wrap="square" lIns="73152" tIns="54864" rIns="73152" bIns="54864" rtlCol="0">
+          <a:bodyPr vert="horz" wrap="square" lIns="0" tIns="12700" rIns="0" bIns="0" rtlCol="0">
             <a:spAutoFit/>
           </a:bodyPr>
           <a:lstStyle/>
@@ -14153,11 +14127,11 @@
               <a:spcBef>
                 <a:spcPts val="100"/>
               </a:spcBef>
-              <a:spcAft>
-                <a:spcPts val="400"/>
-              </a:spcAft>
-              <a:defRPr sz="1400" b="1">
-                <a:latin typeface="Arial"/>
+              <a:defRPr sz="1800">
+                <a:solidFill>
+                  <a:srgbClr val="231F20"/>
+                </a:solidFill>
+                <a:latin typeface="Tahoma"/>
               </a:defRPr>
             </a:pPr>
             <a:r>
@@ -14173,11 +14147,11 @@
               <a:lnSpc>
                 <a:spcPct val="107600"/>
               </a:lnSpc>
-              <a:spcBef>
-                <a:spcPts val="200"/>
-              </a:spcBef>
-              <a:defRPr sz="1200">
-                <a:latin typeface="Arial"/>
+              <a:defRPr sz="1800">
+                <a:solidFill>
+                  <a:srgbClr val="231F20"/>
+                </a:solidFill>
+                <a:latin typeface="Tahoma"/>
               </a:defRPr>
             </a:pPr>
             <a:r>
@@ -14206,7 +14180,7 @@
           </a:prstGeom>
         </p:spPr>
         <p:txBody>
-          <a:bodyPr vert="horz" wrap="square" lIns="73152" tIns="54864" rIns="73152" bIns="54864" rtlCol="0">
+          <a:bodyPr vert="horz" wrap="square" lIns="0" tIns="12700" rIns="0" bIns="0" rtlCol="0">
             <a:spAutoFit/>
           </a:bodyPr>
           <a:lstStyle/>
@@ -14218,11 +14192,9 @@
               <a:spcBef>
                 <a:spcPts val="100"/>
               </a:spcBef>
-              <a:spcAft>
-                <a:spcPts val="400"/>
-              </a:spcAft>
-              <a:defRPr sz="1400" b="1">
-                <a:latin typeface="Arial"/>
+              <a:defRPr sz="1800">
+                <a:solidFill/>
+                <a:latin typeface="Tahoma"/>
               </a:defRPr>
             </a:pPr>
             <a:r>
@@ -14235,11 +14207,8 @@
           </a:p>
           <a:p>
             <a:pPr>
-              <a:spcBef>
-                <a:spcPts val="200"/>
-              </a:spcBef>
-              <a:defRPr sz="1200">
-                <a:latin typeface="Arial"/>
+              <a:defRPr sz="1800">
+                <a:latin typeface="Tahoma"/>
               </a:defRPr>
             </a:pPr>
             <a:r>
@@ -14264,7 +14233,7 @@
           </a:prstGeom>
         </p:spPr>
         <p:txBody>
-          <a:bodyPr vert="horz" wrap="square" lIns="73152" tIns="54864" rIns="73152" bIns="54864" rtlCol="0">
+          <a:bodyPr vert="horz" wrap="square" lIns="0" tIns="33655" rIns="0" bIns="0" rtlCol="0">
             <a:spAutoFit/>
           </a:bodyPr>
           <a:lstStyle/>
@@ -14276,11 +14245,9 @@
               <a:spcBef>
                 <a:spcPts val="265"/>
               </a:spcBef>
-              <a:spcAft>
-                <a:spcPts val="400"/>
-              </a:spcAft>
-              <a:defRPr sz="1400" b="1">
-                <a:latin typeface="Arial"/>
+              <a:defRPr sz="1800">
+                <a:solidFill/>
+                <a:latin typeface="Tahoma"/>
               </a:defRPr>
             </a:pPr>
             <a:r>
@@ -14299,8 +14266,8 @@
               <a:spcBef>
                 <a:spcPts val="165"/>
               </a:spcBef>
-              <a:defRPr sz="1300">
-                <a:latin typeface="Arial"/>
+              <a:defRPr sz="1800">
+                <a:latin typeface="Tahoma"/>
               </a:defRPr>
             </a:pPr>
             <a:r>
@@ -14319,8 +14286,8 @@
               <a:spcBef>
                 <a:spcPts val="165"/>
               </a:spcBef>
-              <a:defRPr sz="1300">
-                <a:latin typeface="Arial"/>
+              <a:defRPr sz="1800">
+                <a:latin typeface="Tahoma"/>
               </a:defRPr>
             </a:pPr>
             <a:r>
@@ -14349,7 +14316,7 @@
           </a:prstGeom>
         </p:spPr>
         <p:txBody>
-          <a:bodyPr vert="horz" wrap="square" lIns="73152" tIns="54864" rIns="73152" bIns="54864" rtlCol="0">
+          <a:bodyPr vert="horz" wrap="square" lIns="0" tIns="410531" rIns="0" bIns="0" rtlCol="0">
             <a:spAutoFit/>
           </a:bodyPr>
           <a:lstStyle/>
@@ -14361,7 +14328,6 @@
               <a:spcBef>
                 <a:spcPts val="100"/>
               </a:spcBef>
-              <a:defRPr/>
             </a:pPr>
             <a:r>
               <a:rPr spc="210" dirty="0"/>
@@ -14446,7 +14412,7 @@
           </a:solidFill>
         </p:spPr>
         <p:txBody>
-          <a:bodyPr wrap="square" lIns="73152" tIns="54864" rIns="73152" bIns="54864" rtlCol="0"/>
+          <a:bodyPr wrap="square" lIns="0" tIns="0" rIns="0" bIns="0" rtlCol="0"/>
           <a:lstStyle/>
           <a:p>
             <a:endParaRPr/>
@@ -14724,7 +14690,7 @@
           </a:solidFill>
         </p:spPr>
         <p:txBody>
-          <a:bodyPr wrap="square" lIns="73152" tIns="54864" rIns="73152" bIns="54864" rtlCol="0"/>
+          <a:bodyPr wrap="square" lIns="0" tIns="0" rIns="0" bIns="0" rtlCol="0"/>
           <a:lstStyle/>
           <a:p>
             <a:endParaRPr/>
@@ -15002,7 +14968,7 @@
           </a:solidFill>
         </p:spPr>
         <p:txBody>
-          <a:bodyPr wrap="square" lIns="73152" tIns="54864" rIns="73152" bIns="54864" rtlCol="0"/>
+          <a:bodyPr wrap="square" lIns="0" tIns="0" rIns="0" bIns="0" rtlCol="0"/>
           <a:lstStyle/>
           <a:p>
             <a:endParaRPr/>
@@ -15280,7 +15246,7 @@
           </a:solidFill>
         </p:spPr>
         <p:txBody>
-          <a:bodyPr wrap="square" lIns="73152" tIns="54864" rIns="73152" bIns="54864" rtlCol="0"/>
+          <a:bodyPr wrap="square" lIns="0" tIns="0" rIns="0" bIns="0" rtlCol="0"/>
           <a:lstStyle/>
           <a:p>
             <a:endParaRPr/>
@@ -15558,7 +15524,7 @@
           </a:solidFill>
         </p:spPr>
         <p:txBody>
-          <a:bodyPr wrap="square" lIns="73152" tIns="54864" rIns="73152" bIns="54864" rtlCol="0"/>
+          <a:bodyPr wrap="square" lIns="0" tIns="0" rIns="0" bIns="0" rtlCol="0"/>
           <a:lstStyle/>
           <a:p>
             <a:endParaRPr/>
@@ -15836,7 +15802,7 @@
           </a:solidFill>
         </p:spPr>
         <p:txBody>
-          <a:bodyPr wrap="square" lIns="73152" tIns="54864" rIns="73152" bIns="54864" rtlCol="0"/>
+          <a:bodyPr wrap="square" lIns="0" tIns="0" rIns="0" bIns="0" rtlCol="0"/>
           <a:lstStyle/>
           <a:p>
             <a:endParaRPr/>
@@ -19867,7 +19833,7 @@
           </a:prstGeom>
         </p:spPr>
         <p:txBody>
-          <a:bodyPr vert="horz" wrap="square" lIns="73152" tIns="54864" rIns="73152" bIns="54864" rtlCol="0">
+          <a:bodyPr vert="horz" wrap="square" lIns="0" tIns="15875" rIns="0" bIns="0" rtlCol="0">
             <a:spAutoFit/>
           </a:bodyPr>
           <a:lstStyle/>
@@ -19879,11 +19845,9 @@
               <a:spcBef>
                 <a:spcPts val="125"/>
               </a:spcBef>
-              <a:spcAft>
-                <a:spcPts val="400"/>
-              </a:spcAft>
-              <a:defRPr sz="1400" b="1">
-                <a:latin typeface="Arial"/>
+              <a:defRPr sz="8500">
+                <a:solidFill/>
+                <a:latin typeface="Tahoma"/>
               </a:defRPr>
             </a:pPr>
             <a:r>
@@ -19900,10 +19864,10 @@
                 <a:spcPct val="100000"/>
               </a:lnSpc>
               <a:spcBef>
-                <a:spcPts val="200"/>
+                <a:spcPts val="155"/>
               </a:spcBef>
-              <a:defRPr sz="1200">
-                <a:latin typeface="Arial"/>
+              <a:defRPr sz="8500">
+                <a:latin typeface="Tahoma"/>
               </a:defRPr>
             </a:pPr>
             <a:r>
@@ -19932,7 +19896,7 @@
           </a:prstGeom>
         </p:spPr>
         <p:txBody>
-          <a:bodyPr vert="horz" wrap="square" lIns="73152" tIns="54864" rIns="73152" bIns="54864" rtlCol="0">
+          <a:bodyPr vert="horz" wrap="square" lIns="0" tIns="1636678" rIns="0" bIns="0" rtlCol="0">
             <a:spAutoFit/>
           </a:bodyPr>
           <a:lstStyle/>
@@ -19944,7 +19908,6 @@
               <a:spcBef>
                 <a:spcPts val="105"/>
               </a:spcBef>
-              <a:defRPr/>
             </a:pPr>
             <a:r>
               <a:rPr sz="4100" spc="165" dirty="0">
@@ -19990,7 +19953,7 @@
           </a:prstGeom>
         </p:spPr>
         <p:txBody>
-          <a:bodyPr vert="horz" wrap="square" lIns="73152" tIns="54864" rIns="73152" bIns="54864" rtlCol="0">
+          <a:bodyPr vert="horz" wrap="square" lIns="0" tIns="15240" rIns="0" bIns="0" rtlCol="0">
             <a:spAutoFit/>
           </a:bodyPr>
           <a:lstStyle/>
@@ -20002,8 +19965,9 @@
               <a:spcBef>
                 <a:spcPts val="120"/>
               </a:spcBef>
-              <a:defRPr sz="1300" b="1">
-                <a:latin typeface="Arial"/>
+              <a:defRPr sz="2650">
+                <a:solidFill/>
+                <a:latin typeface="Verdana"/>
               </a:defRPr>
             </a:pPr>
             <a:r>
@@ -20032,7 +19996,7 @@
           </a:prstGeom>
         </p:spPr>
         <p:txBody>
-          <a:bodyPr vert="horz" wrap="square" lIns="73152" tIns="54864" rIns="73152" bIns="54864" rtlCol="0">
+          <a:bodyPr vert="horz" wrap="square" lIns="0" tIns="15240" rIns="0" bIns="0" rtlCol="0">
             <a:spAutoFit/>
           </a:bodyPr>
           <a:lstStyle/>
@@ -20044,8 +20008,9 @@
               <a:spcBef>
                 <a:spcPts val="120"/>
               </a:spcBef>
-              <a:defRPr sz="1300" b="1">
-                <a:latin typeface="Arial"/>
+              <a:defRPr sz="2250">
+                <a:solidFill/>
+                <a:latin typeface="Verdana"/>
               </a:defRPr>
             </a:pPr>
             <a:r>
@@ -20074,7 +20039,7 @@
           </a:prstGeom>
         </p:spPr>
         <p:txBody>
-          <a:bodyPr vert="horz" wrap="square" lIns="73152" tIns="54864" rIns="73152" bIns="54864" rtlCol="0">
+          <a:bodyPr vert="horz" wrap="square" lIns="0" tIns="15240" rIns="0" bIns="0" rtlCol="0">
             <a:spAutoFit/>
           </a:bodyPr>
           <a:lstStyle/>
@@ -20086,8 +20051,9 @@
               <a:spcBef>
                 <a:spcPts val="120"/>
               </a:spcBef>
-              <a:defRPr sz="1300" b="1">
-                <a:latin typeface="Arial"/>
+              <a:defRPr sz="2700">
+                <a:solidFill/>
+                <a:latin typeface="Verdana"/>
               </a:defRPr>
             </a:pPr>
             <a:r>
@@ -20116,7 +20082,7 @@
           </a:prstGeom>
         </p:spPr>
         <p:txBody>
-          <a:bodyPr vert="horz" wrap="square" lIns="73152" tIns="54864" rIns="73152" bIns="54864" rtlCol="0">
+          <a:bodyPr vert="horz" wrap="square" lIns="0" tIns="15875" rIns="0" bIns="0" rtlCol="0">
             <a:spAutoFit/>
           </a:bodyPr>
           <a:lstStyle/>
@@ -20128,8 +20094,9 @@
               <a:spcBef>
                 <a:spcPts val="125"/>
               </a:spcBef>
-              <a:defRPr sz="1300" b="1">
-                <a:latin typeface="Arial"/>
+              <a:defRPr sz="2450">
+                <a:solidFill/>
+                <a:latin typeface="Verdana"/>
               </a:defRPr>
             </a:pPr>
             <a:r>
@@ -20399,7 +20366,7 @@
           </a:solidFill>
         </p:spPr>
         <p:txBody>
-          <a:bodyPr wrap="square" lIns="73152" tIns="54864" rIns="73152" bIns="54864" rtlCol="0"/>
+          <a:bodyPr wrap="square" lIns="0" tIns="0" rIns="0" bIns="0" rtlCol="0"/>
           <a:lstStyle/>
           <a:p>
             <a:endParaRPr/>
@@ -20587,7 +20554,7 @@
           </a:solidFill>
         </p:spPr>
         <p:txBody>
-          <a:bodyPr wrap="square" lIns="73152" tIns="54864" rIns="73152" bIns="54864" rtlCol="0"/>
+          <a:bodyPr wrap="square" lIns="0" tIns="0" rIns="0" bIns="0" rtlCol="0"/>
           <a:lstStyle/>
           <a:p>
             <a:endParaRPr/>
@@ -20610,7 +20577,7 @@
           </a:prstGeom>
         </p:spPr>
         <p:txBody>
-          <a:bodyPr vert="horz" wrap="square" lIns="73152" tIns="54864" rIns="73152" bIns="54864" rtlCol="0">
+          <a:bodyPr vert="horz" wrap="square" lIns="0" tIns="12700" rIns="0" bIns="0" rtlCol="0">
             <a:spAutoFit/>
           </a:bodyPr>
           <a:lstStyle/>
@@ -20622,8 +20589,11 @@
               <a:spcBef>
                 <a:spcPts val="100"/>
               </a:spcBef>
-              <a:defRPr sz="1300" b="1">
-                <a:latin typeface="Arial"/>
+              <a:defRPr sz="3000">
+                <a:solidFill>
+                  <a:srgbClr val="383636"/>
+                </a:solidFill>
+                <a:latin typeface="Tahoma"/>
               </a:defRPr>
             </a:pPr>
             <a:r>
@@ -20817,7 +20787,7 @@
           </a:solidFill>
         </p:spPr>
         <p:txBody>
-          <a:bodyPr wrap="square" lIns="73152" tIns="54864" rIns="73152" bIns="54864" rtlCol="0"/>
+          <a:bodyPr wrap="square" lIns="0" tIns="0" rIns="0" bIns="0" rtlCol="0"/>
           <a:lstStyle/>
           <a:p>
             <a:endParaRPr/>
@@ -21005,7 +20975,7 @@
           </a:solidFill>
         </p:spPr>
         <p:txBody>
-          <a:bodyPr wrap="square" lIns="73152" tIns="54864" rIns="73152" bIns="54864" rtlCol="0"/>
+          <a:bodyPr wrap="square" lIns="0" tIns="0" rIns="0" bIns="0" rtlCol="0"/>
           <a:lstStyle/>
           <a:p>
             <a:endParaRPr/>
@@ -21050,7 +21020,7 @@
           </a:prstGeom>
         </p:spPr>
         <p:txBody>
-          <a:bodyPr vert="horz" wrap="square" lIns="73152" tIns="54864" rIns="73152" bIns="54864" rtlCol="0">
+          <a:bodyPr vert="horz" wrap="square" lIns="0" tIns="12700" rIns="0" bIns="0" rtlCol="0">
             <a:spAutoFit/>
           </a:bodyPr>
           <a:lstStyle/>
@@ -21062,7 +21032,6 @@
               <a:spcBef>
                 <a:spcPts val="100"/>
               </a:spcBef>
-              <a:defRPr/>
             </a:pPr>
             <a:r>
               <a:rPr sz="3950" b="1" spc="50" dirty="0">
@@ -21097,7 +21066,7 @@
           </a:prstGeom>
         </p:spPr>
         <p:txBody>
-          <a:bodyPr vert="horz" wrap="square" lIns="73152" tIns="54864" rIns="73152" bIns="54864" rtlCol="0">
+          <a:bodyPr vert="horz" wrap="square" lIns="0" tIns="1063230" rIns="0" bIns="0" rtlCol="0">
             <a:spAutoFit/>
           </a:bodyPr>
           <a:lstStyle/>
@@ -21109,7 +21078,6 @@
               <a:spcBef>
                 <a:spcPts val="100"/>
               </a:spcBef>
-              <a:defRPr/>
             </a:pPr>
             <a:r>
               <a:rPr sz="5500" spc="155" dirty="0"/>
@@ -21143,7 +21111,7 @@
           </a:prstGeom>
         </p:spPr>
         <p:txBody>
-          <a:bodyPr vert="horz" wrap="square" lIns="73152" tIns="54864" rIns="73152" bIns="54864" rtlCol="0">
+          <a:bodyPr vert="horz" wrap="square" lIns="0" tIns="12700" rIns="0" bIns="0" rtlCol="0">
             <a:spAutoFit/>
           </a:bodyPr>
           <a:lstStyle/>
@@ -21155,8 +21123,11 @@
               <a:spcBef>
                 <a:spcPts val="100"/>
               </a:spcBef>
-              <a:defRPr sz="1300" b="1">
-                <a:latin typeface="Arial"/>
+              <a:defRPr sz="3000">
+                <a:solidFill>
+                  <a:srgbClr val="383636"/>
+                </a:solidFill>
+                <a:latin typeface="Tahoma"/>
               </a:defRPr>
             </a:pPr>
             <a:r>
@@ -21185,7 +21156,7 @@
           </a:prstGeom>
         </p:spPr>
         <p:txBody>
-          <a:bodyPr vert="horz" wrap="square" lIns="73152" tIns="54864" rIns="73152" bIns="54864" rtlCol="0">
+          <a:bodyPr vert="horz" wrap="square" lIns="0" tIns="12700" rIns="0" bIns="0" rtlCol="0">
             <a:spAutoFit/>
           </a:bodyPr>
           <a:lstStyle/>
@@ -21197,8 +21168,11 @@
               <a:spcBef>
                 <a:spcPts val="100"/>
               </a:spcBef>
-              <a:defRPr sz="1300" b="1">
-                <a:latin typeface="Arial"/>
+              <a:defRPr sz="3000">
+                <a:solidFill>
+                  <a:srgbClr val="383636"/>
+                </a:solidFill>
+                <a:latin typeface="Arial Black"/>
               </a:defRPr>
             </a:pPr>
             <a:r>
@@ -21227,7 +21201,7 @@
           </a:prstGeom>
         </p:spPr>
         <p:txBody>
-          <a:bodyPr vert="horz" wrap="square" lIns="73152" tIns="54864" rIns="73152" bIns="54864" rtlCol="0">
+          <a:bodyPr vert="horz" wrap="square" lIns="0" tIns="12700" rIns="0" bIns="0" rtlCol="0">
             <a:spAutoFit/>
           </a:bodyPr>
           <a:lstStyle/>
@@ -21239,8 +21213,11 @@
               <a:spcBef>
                 <a:spcPts val="100"/>
               </a:spcBef>
-              <a:defRPr sz="1300" b="1">
-                <a:latin typeface="Arial"/>
+              <a:defRPr sz="3000">
+                <a:solidFill>
+                  <a:srgbClr val="383636"/>
+                </a:solidFill>
+                <a:latin typeface="Tahoma"/>
               </a:defRPr>
             </a:pPr>
             <a:r>
@@ -21434,7 +21411,7 @@
           </a:solidFill>
         </p:spPr>
         <p:txBody>
-          <a:bodyPr wrap="square" lIns="73152" tIns="54864" rIns="73152" bIns="54864" rtlCol="0"/>
+          <a:bodyPr wrap="square" lIns="0" tIns="0" rIns="0" bIns="0" rtlCol="0"/>
           <a:lstStyle/>
           <a:p>
             <a:endParaRPr/>
@@ -21479,7 +21456,7 @@
           </a:prstGeom>
         </p:spPr>
         <p:txBody>
-          <a:bodyPr vert="horz" wrap="square" lIns="73152" tIns="54864" rIns="73152" bIns="54864" rtlCol="0">
+          <a:bodyPr vert="horz" wrap="square" lIns="0" tIns="12700" rIns="0" bIns="0" rtlCol="0">
             <a:spAutoFit/>
           </a:bodyPr>
           <a:lstStyle/>
@@ -21489,10 +21466,13 @@
                 <a:spcPct val="112900"/>
               </a:lnSpc>
               <a:spcBef>
-                <a:spcPts val="300"/>
+                <a:spcPts val="100"/>
               </a:spcBef>
-              <a:defRPr sz="1150">
-                <a:latin typeface="Arial"/>
+              <a:defRPr sz="1550">
+                <a:solidFill>
+                  <a:srgbClr val="383636"/>
+                </a:solidFill>
+                <a:latin typeface="Tahoma"/>
               </a:defRPr>
             </a:pPr>
             <a:r>
@@ -21521,7 +21501,7 @@
           </a:prstGeom>
         </p:spPr>
         <p:txBody>
-          <a:bodyPr vert="horz" wrap="square" lIns="73152" tIns="54864" rIns="73152" bIns="54864" rtlCol="0">
+          <a:bodyPr vert="horz" wrap="square" lIns="0" tIns="12700" rIns="0" bIns="0" rtlCol="0">
             <a:spAutoFit/>
           </a:bodyPr>
           <a:lstStyle/>
@@ -21533,7 +21513,6 @@
               <a:spcBef>
                 <a:spcPts val="100"/>
               </a:spcBef>
-              <a:defRPr/>
             </a:pPr>
             <a:r>
               <a:rPr sz="1550" b="1" dirty="0">
@@ -28855,7 +28834,7 @@
           </a:prstGeom>
         </p:spPr>
         <p:txBody>
-          <a:bodyPr vert="horz" wrap="square" lIns="73152" tIns="54864" rIns="73152" bIns="54864" rtlCol="0">
+          <a:bodyPr vert="horz" wrap="square" lIns="0" tIns="12700" rIns="0" bIns="0" rtlCol="0">
             <a:spAutoFit/>
           </a:bodyPr>
           <a:lstStyle/>
@@ -28867,7 +28846,6 @@
               <a:spcBef>
                 <a:spcPts val="100"/>
               </a:spcBef>
-              <a:defRPr/>
             </a:pPr>
             <a:r>
               <a:rPr sz="1800" spc="-25" dirty="0">
@@ -28902,7 +28880,7 @@
           </a:prstGeom>
         </p:spPr>
         <p:txBody>
-          <a:bodyPr vert="horz" wrap="square" lIns="73152" tIns="54864" rIns="73152" bIns="54864" rtlCol="0">
+          <a:bodyPr vert="horz" wrap="square" lIns="0" tIns="12700" rIns="0" bIns="0" rtlCol="0">
             <a:spAutoFit/>
           </a:bodyPr>
           <a:lstStyle/>
@@ -28914,7 +28892,6 @@
               <a:spcBef>
                 <a:spcPts val="100"/>
               </a:spcBef>
-              <a:defRPr/>
             </a:pPr>
             <a:r>
               <a:rPr sz="1800" spc="-25" dirty="0">
@@ -28949,7 +28926,7 @@
           </a:prstGeom>
         </p:spPr>
         <p:txBody>
-          <a:bodyPr vert="horz" wrap="square" lIns="73152" tIns="54864" rIns="73152" bIns="54864" rtlCol="0">
+          <a:bodyPr vert="horz" wrap="square" lIns="0" tIns="12700" rIns="0" bIns="0" rtlCol="0">
             <a:spAutoFit/>
           </a:bodyPr>
           <a:lstStyle/>
@@ -28961,7 +28938,6 @@
               <a:spcBef>
                 <a:spcPts val="100"/>
               </a:spcBef>
-              <a:defRPr/>
             </a:pPr>
             <a:r>
               <a:rPr sz="1800" spc="-25" dirty="0">
@@ -28983,7 +28959,6 @@
               <a:lnSpc>
                 <a:spcPts val="2120"/>
               </a:lnSpc>
-              <a:defRPr/>
             </a:pPr>
             <a:r>
               <a:rPr sz="1800" spc="-25" dirty="0">
@@ -29099,7 +29074,7 @@
           </a:prstGeom>
         </p:spPr>
         <p:txBody>
-          <a:bodyPr vert="horz" wrap="square" lIns="73152" tIns="54864" rIns="73152" bIns="54864" rtlCol="0">
+          <a:bodyPr vert="horz" wrap="square" lIns="0" tIns="64135" rIns="0" bIns="0" rtlCol="0">
             <a:spAutoFit/>
           </a:bodyPr>
           <a:lstStyle/>
@@ -29111,7 +29086,6 @@
               <a:spcBef>
                 <a:spcPts val="505"/>
               </a:spcBef>
-              <a:defRPr/>
             </a:pPr>
             <a:r>
               <a:rPr sz="2100" spc="-10" dirty="0">
@@ -29144,7 +29118,6 @@
               <a:lnSpc>
                 <a:spcPct val="116100"/>
               </a:lnSpc>
-              <a:defRPr/>
             </a:pPr>
             <a:r>
               <a:rPr sz="2100" spc="-10" dirty="0">
@@ -29191,7 +29164,6 @@
               <a:lnSpc>
                 <a:spcPct val="116100"/>
               </a:lnSpc>
-              <a:defRPr/>
             </a:pPr>
             <a:r>
               <a:rPr sz="2100" dirty="0">
@@ -29272,7 +29244,7 @@
           </a:prstGeom>
         </p:spPr>
         <p:txBody>
-          <a:bodyPr vert="horz" wrap="square" lIns="73152" tIns="54864" rIns="73152" bIns="54864" rtlCol="0">
+          <a:bodyPr vert="horz" wrap="square" lIns="0" tIns="64135" rIns="0" bIns="0" rtlCol="0">
             <a:spAutoFit/>
           </a:bodyPr>
           <a:lstStyle/>
@@ -29284,7 +29256,6 @@
               <a:spcBef>
                 <a:spcPts val="505"/>
               </a:spcBef>
-              <a:defRPr/>
             </a:pPr>
             <a:r>
               <a:rPr sz="2100" dirty="0">
@@ -29317,7 +29288,6 @@
               <a:lnSpc>
                 <a:spcPct val="116100"/>
               </a:lnSpc>
-              <a:defRPr/>
             </a:pPr>
             <a:r>
               <a:rPr sz="2100" dirty="0">
@@ -29377,7 +29347,7 @@
           </a:prstGeom>
         </p:spPr>
         <p:txBody>
-          <a:bodyPr vert="horz" wrap="square" lIns="73152" tIns="54864" rIns="73152" bIns="54864" rtlCol="0">
+          <a:bodyPr vert="horz" wrap="square" lIns="0" tIns="12700" rIns="0" bIns="0" rtlCol="0">
             <a:spAutoFit/>
           </a:bodyPr>
           <a:lstStyle/>
@@ -29389,7 +29359,6 @@
               <a:spcBef>
                 <a:spcPts val="100"/>
               </a:spcBef>
-              <a:defRPr/>
             </a:pPr>
             <a:r>
               <a:rPr sz="2100" spc="-70" dirty="0">
@@ -29492,7 +29461,6 @@
               <a:lnSpc>
                 <a:spcPct val="116100"/>
               </a:lnSpc>
-              <a:defRPr/>
             </a:pPr>
             <a:r>
               <a:rPr sz="2100" spc="-10" dirty="0">
@@ -29545,7 +29513,7 @@
           </a:prstGeom>
         </p:spPr>
         <p:txBody>
-          <a:bodyPr vert="horz" wrap="square" lIns="73152" tIns="54864" rIns="73152" bIns="54864" rtlCol="0">
+          <a:bodyPr vert="horz" wrap="square" lIns="0" tIns="12700" rIns="0" bIns="0" rtlCol="0">
             <a:spAutoFit/>
           </a:bodyPr>
           <a:lstStyle/>
@@ -29557,7 +29525,6 @@
               <a:spcBef>
                 <a:spcPts val="100"/>
               </a:spcBef>
-              <a:defRPr/>
             </a:pPr>
             <a:r>
               <a:rPr sz="2100" spc="75" dirty="0">
@@ -29680,7 +29647,7 @@
           </a:prstGeom>
         </p:spPr>
         <p:txBody>
-          <a:bodyPr vert="horz" wrap="square" lIns="73152" tIns="54864" rIns="73152" bIns="54864" rtlCol="0">
+          <a:bodyPr vert="horz" wrap="square" lIns="0" tIns="11430" rIns="0" bIns="0" rtlCol="0">
             <a:spAutoFit/>
           </a:bodyPr>
           <a:lstStyle/>
@@ -29692,7 +29659,6 @@
               <a:spcBef>
                 <a:spcPts val="90"/>
               </a:spcBef>
-              <a:defRPr/>
             </a:pPr>
             <a:r>
               <a:rPr sz="2050" dirty="0">
@@ -29777,7 +29743,6 @@
               <a:spcBef>
                 <a:spcPts val="105"/>
               </a:spcBef>
-              <a:defRPr/>
             </a:pPr>
             <a:r>
               <a:rPr sz="2050" dirty="0">
@@ -29844,7 +29809,7 @@
           </a:prstGeom>
         </p:spPr>
         <p:txBody>
-          <a:bodyPr vert="horz" wrap="square" lIns="73152" tIns="54864" rIns="73152" bIns="54864" rtlCol="0">
+          <a:bodyPr vert="horz" wrap="square" lIns="0" tIns="11430" rIns="0" bIns="0" rtlCol="0">
             <a:spAutoFit/>
           </a:bodyPr>
           <a:lstStyle/>
@@ -29856,7 +29821,6 @@
               <a:spcBef>
                 <a:spcPts val="90"/>
               </a:spcBef>
-              <a:defRPr/>
             </a:pPr>
             <a:r>
               <a:rPr sz="2050" spc="-10" dirty="0">
@@ -29916,7 +29880,7 @@
           </a:prstGeom>
         </p:spPr>
         <p:txBody>
-          <a:bodyPr vert="horz" wrap="square" lIns="73152" tIns="54864" rIns="73152" bIns="54864" rtlCol="0">
+          <a:bodyPr vert="horz" wrap="square" lIns="0" tIns="10795" rIns="0" bIns="0" rtlCol="0">
             <a:spAutoFit/>
           </a:bodyPr>
           <a:lstStyle/>
@@ -29926,10 +29890,11 @@
                 <a:spcPct val="114300"/>
               </a:lnSpc>
               <a:spcBef>
-                <a:spcPts val="200"/>
+                <a:spcPts val="85"/>
               </a:spcBef>
-              <a:defRPr sz="1200">
-                <a:latin typeface="Arial"/>
+              <a:defRPr sz="2450">
+                <a:solidFill/>
+                <a:latin typeface="Arial Black"/>
               </a:defRPr>
             </a:pPr>
             <a:r>
@@ -29958,7 +29923,7 @@
           </a:prstGeom>
         </p:spPr>
         <p:txBody>
-          <a:bodyPr vert="horz" wrap="square" lIns="73152" tIns="54864" rIns="73152" bIns="54864" rtlCol="0">
+          <a:bodyPr vert="horz" wrap="square" lIns="0" tIns="12065" rIns="0" bIns="0" rtlCol="0">
             <a:spAutoFit/>
           </a:bodyPr>
           <a:lstStyle/>
@@ -29968,10 +29933,11 @@
                 <a:spcPct val="116300"/>
               </a:lnSpc>
               <a:spcBef>
-                <a:spcPts val="200"/>
+                <a:spcPts val="95"/>
               </a:spcBef>
-              <a:defRPr sz="1200">
-                <a:latin typeface="Arial"/>
+              <a:defRPr sz="2150">
+                <a:solidFill/>
+                <a:latin typeface="Arial Black"/>
               </a:defRPr>
             </a:pPr>
             <a:r>
@@ -30000,7 +29966,7 @@
           </a:prstGeom>
         </p:spPr>
         <p:txBody>
-          <a:bodyPr vert="horz" wrap="square" lIns="73152" tIns="54864" rIns="73152" bIns="54864" rtlCol="0">
+          <a:bodyPr vert="horz" wrap="square" lIns="0" tIns="12065" rIns="0" bIns="0" rtlCol="0">
             <a:spAutoFit/>
           </a:bodyPr>
           <a:lstStyle/>
@@ -30010,10 +29976,11 @@
                 <a:spcPct val="116700"/>
               </a:lnSpc>
               <a:spcBef>
-                <a:spcPts val="200"/>
+                <a:spcPts val="95"/>
               </a:spcBef>
-              <a:defRPr sz="1200">
-                <a:latin typeface="Arial"/>
+              <a:defRPr sz="2250">
+                <a:solidFill/>
+                <a:latin typeface="Arial Black"/>
               </a:defRPr>
             </a:pPr>
             <a:r>
@@ -30042,7 +30009,7 @@
           </a:prstGeom>
         </p:spPr>
         <p:txBody>
-          <a:bodyPr vert="horz" wrap="square" lIns="73152" tIns="54864" rIns="73152" bIns="54864" rtlCol="0">
+          <a:bodyPr vert="horz" wrap="square" lIns="0" tIns="627175" rIns="0" bIns="0" rtlCol="0">
             <a:spAutoFit/>
           </a:bodyPr>
           <a:lstStyle/>
@@ -30054,7 +30021,6 @@
               <a:spcBef>
                 <a:spcPts val="100"/>
               </a:spcBef>
-              <a:defRPr/>
             </a:pPr>
             <a:r>
               <a:rPr spc="130" dirty="0"/>
@@ -30112,7 +30078,7 @@
           </a:prstGeom>
         </p:spPr>
         <p:txBody>
-          <a:bodyPr vert="horz" wrap="square" lIns="73152" tIns="54864" rIns="73152" bIns="54864" rtlCol="0">
+          <a:bodyPr vert="horz" wrap="square" lIns="0" tIns="12065" rIns="0" bIns="0" rtlCol="0">
             <a:spAutoFit/>
           </a:bodyPr>
           <a:lstStyle/>
@@ -30124,7 +30090,6 @@
               <a:spcBef>
                 <a:spcPts val="95"/>
               </a:spcBef>
-              <a:defRPr/>
             </a:pPr>
             <a:r>
               <a:rPr sz="2450" b="1" spc="60" dirty="0">
@@ -30177,7 +30142,7 @@
           </a:prstGeom>
         </p:spPr>
         <p:txBody>
-          <a:bodyPr vert="horz" wrap="square" lIns="73152" tIns="54864" rIns="73152" bIns="54864" rtlCol="0">
+          <a:bodyPr vert="horz" wrap="square" lIns="0" tIns="12065" rIns="0" bIns="0" rtlCol="0">
             <a:spAutoFit/>
           </a:bodyPr>
           <a:lstStyle/>
@@ -30189,11 +30154,9 @@
               <a:spcBef>
                 <a:spcPts val="95"/>
               </a:spcBef>
-              <a:spcAft>
-                <a:spcPts val="400"/>
-              </a:spcAft>
-              <a:defRPr sz="1400" b="1">
-                <a:latin typeface="Arial"/>
+              <a:defRPr sz="2300">
+                <a:solidFill/>
+                <a:latin typeface="Arial Black"/>
               </a:defRPr>
             </a:pPr>
             <a:r>
@@ -30210,10 +30173,10 @@
                 <a:spcPct val="116799"/>
               </a:lnSpc>
               <a:spcBef>
-                <a:spcPts val="200"/>
+                <a:spcPts val="1280"/>
               </a:spcBef>
-              <a:defRPr sz="1200">
-                <a:latin typeface="Arial"/>
+              <a:defRPr sz="2300">
+                <a:latin typeface="Arial Black"/>
               </a:defRPr>
             </a:pPr>
             <a:r>
@@ -30242,7 +30205,7 @@
           </a:prstGeom>
         </p:spPr>
         <p:txBody>
-          <a:bodyPr vert="horz" wrap="square" lIns="73152" tIns="54864" rIns="73152" bIns="54864" rtlCol="0">
+          <a:bodyPr vert="horz" wrap="square" lIns="0" tIns="12065" rIns="0" bIns="0" rtlCol="0">
             <a:spAutoFit/>
           </a:bodyPr>
           <a:lstStyle/>
@@ -30254,7 +30217,6 @@
               <a:spcBef>
                 <a:spcPts val="95"/>
               </a:spcBef>
-              <a:defRPr/>
             </a:pPr>
             <a:r>
               <a:rPr sz="1650" spc="-95" dirty="0">
@@ -30349,7 +30311,7 @@
           </a:prstGeom>
         </p:spPr>
         <p:txBody>
-          <a:bodyPr vert="horz" wrap="square" lIns="73152" tIns="54864" rIns="73152" bIns="54864" rtlCol="0">
+          <a:bodyPr vert="horz" wrap="square" lIns="0" tIns="12065" rIns="0" bIns="0" rtlCol="0">
             <a:spAutoFit/>
           </a:bodyPr>
           <a:lstStyle/>
@@ -30361,7 +30323,6 @@
               <a:spcBef>
                 <a:spcPts val="95"/>
               </a:spcBef>
-              <a:defRPr/>
             </a:pPr>
             <a:r>
               <a:rPr sz="1650" b="1" dirty="0">
@@ -30435,7 +30396,7 @@
           </a:prstGeom>
         </p:spPr>
         <p:txBody>
-          <a:bodyPr vert="horz" wrap="square" lIns="73152" tIns="54864" rIns="73152" bIns="54864" rtlCol="0">
+          <a:bodyPr vert="horz" wrap="square" lIns="0" tIns="12700" rIns="0" bIns="0" rtlCol="0">
             <a:spAutoFit/>
           </a:bodyPr>
           <a:lstStyle/>
@@ -30447,11 +30408,9 @@
               <a:spcBef>
                 <a:spcPts val="100"/>
               </a:spcBef>
-              <a:spcAft>
-                <a:spcPts val="400"/>
-              </a:spcAft>
-              <a:defRPr sz="1400" b="1">
-                <a:latin typeface="Arial"/>
+              <a:defRPr sz="2300">
+                <a:solidFill/>
+                <a:latin typeface="Roboto"/>
               </a:defRPr>
             </a:pPr>
             <a:r>
@@ -30468,10 +30427,10 @@
                 <a:spcPct val="114599"/>
               </a:lnSpc>
               <a:spcBef>
-                <a:spcPts val="200"/>
+                <a:spcPts val="1495"/>
               </a:spcBef>
-              <a:defRPr sz="1200">
-                <a:latin typeface="Arial"/>
+              <a:defRPr sz="2300">
+                <a:latin typeface="Roboto"/>
               </a:defRPr>
             </a:pPr>
             <a:r>
@@ -30500,7 +30459,7 @@
           </a:prstGeom>
         </p:spPr>
         <p:txBody>
-          <a:bodyPr vert="horz" wrap="square" lIns="73152" tIns="54864" rIns="73152" bIns="54864" rtlCol="0">
+          <a:bodyPr vert="horz" wrap="square" lIns="0" tIns="12700" rIns="0" bIns="0" rtlCol="0">
             <a:spAutoFit/>
           </a:bodyPr>
           <a:lstStyle/>
@@ -30512,7 +30471,6 @@
               <a:spcBef>
                 <a:spcPts val="100"/>
               </a:spcBef>
-              <a:defRPr/>
             </a:pPr>
             <a:r>
               <a:rPr sz="1700" b="1" dirty="0">
@@ -30600,7 +30558,7 @@
           </a:prstGeom>
         </p:spPr>
         <p:txBody>
-          <a:bodyPr vert="horz" wrap="square" lIns="73152" tIns="54864" rIns="73152" bIns="54864" rtlCol="0">
+          <a:bodyPr vert="horz" wrap="square" lIns="0" tIns="12700" rIns="0" bIns="0" rtlCol="0">
             <a:spAutoFit/>
           </a:bodyPr>
           <a:lstStyle/>
@@ -30612,7 +30570,6 @@
               <a:spcBef>
                 <a:spcPts val="100"/>
               </a:spcBef>
-              <a:defRPr/>
             </a:pPr>
             <a:r>
               <a:rPr sz="1500" b="1" dirty="0">
@@ -30707,7 +30664,7 @@
           </a:prstGeom>
         </p:spPr>
         <p:txBody>
-          <a:bodyPr vert="horz" wrap="square" lIns="73152" tIns="54864" rIns="73152" bIns="54864" rtlCol="0">
+          <a:bodyPr vert="horz" wrap="square" lIns="0" tIns="12700" rIns="0" bIns="0" rtlCol="0">
             <a:spAutoFit/>
           </a:bodyPr>
           <a:lstStyle/>
@@ -30719,11 +30676,9 @@
               <a:spcBef>
                 <a:spcPts val="100"/>
               </a:spcBef>
-              <a:spcAft>
-                <a:spcPts val="400"/>
-              </a:spcAft>
-              <a:defRPr sz="1400" b="1">
-                <a:latin typeface="Arial"/>
+              <a:defRPr sz="2300">
+                <a:solidFill/>
+                <a:latin typeface="Arial Black"/>
               </a:defRPr>
             </a:pPr>
             <a:r>
@@ -30740,10 +30695,10 @@
                 <a:spcPct val="114599"/>
               </a:lnSpc>
               <a:spcBef>
-                <a:spcPts val="200"/>
+                <a:spcPts val="885"/>
               </a:spcBef>
-              <a:defRPr sz="1200">
-                <a:latin typeface="Arial"/>
+              <a:defRPr sz="2300">
+                <a:latin typeface="Arial Black"/>
               </a:defRPr>
             </a:pPr>
             <a:r>
@@ -30772,7 +30727,7 @@
           </a:prstGeom>
         </p:spPr>
         <p:txBody>
-          <a:bodyPr vert="horz" wrap="square" lIns="73152" tIns="54864" rIns="73152" bIns="54864" rtlCol="0">
+          <a:bodyPr vert="horz" wrap="square" lIns="0" tIns="12700" rIns="0" bIns="0" rtlCol="0">
             <a:spAutoFit/>
           </a:bodyPr>
           <a:lstStyle/>
@@ -30784,7 +30739,6 @@
               <a:spcBef>
                 <a:spcPts val="100"/>
               </a:spcBef>
-              <a:defRPr/>
             </a:pPr>
             <a:r>
               <a:rPr sz="1800" b="1" spc="-25" dirty="0">
@@ -30872,7 +30826,7 @@
           </a:prstGeom>
         </p:spPr>
         <p:txBody>
-          <a:bodyPr vert="horz" wrap="square" lIns="73152" tIns="54864" rIns="73152" bIns="54864" rtlCol="0">
+          <a:bodyPr vert="horz" wrap="square" lIns="0" tIns="12700" rIns="0" bIns="0" rtlCol="0">
             <a:spAutoFit/>
           </a:bodyPr>
           <a:lstStyle/>
@@ -30884,7 +30838,6 @@
               <a:spcBef>
                 <a:spcPts val="100"/>
               </a:spcBef>
-              <a:defRPr/>
             </a:pPr>
             <a:r>
               <a:rPr sz="1700" b="1" dirty="0">
@@ -31031,7 +30984,7 @@
           </a:solidFill>
         </p:spPr>
         <p:txBody>
-          <a:bodyPr wrap="square" lIns="73152" tIns="54864" rIns="73152" bIns="54864" rtlCol="0"/>
+          <a:bodyPr wrap="square" lIns="0" tIns="0" rIns="0" bIns="0" rtlCol="0"/>
           <a:lstStyle/>
           <a:p>
             <a:endParaRPr/>
@@ -32737,7 +32690,7 @@
           </a:prstGeom>
         </p:spPr>
         <p:txBody>
-          <a:bodyPr vert="horz" wrap="square" lIns="73152" tIns="54864" rIns="73152" bIns="54864" rtlCol="0">
+          <a:bodyPr vert="horz" wrap="square" lIns="0" tIns="12700" rIns="0" bIns="0" rtlCol="0">
             <a:spAutoFit/>
           </a:bodyPr>
           <a:lstStyle/>
@@ -32749,8 +32702,10 @@
               <a:spcBef>
                 <a:spcPts val="100"/>
               </a:spcBef>
-              <a:defRPr sz="1300" b="1">
-                <a:latin typeface="Arial"/>
+              <a:defRPr sz="5000">
+                <a:solidFill>
+                  <a:srgbClr val="E36670"/>
+                </a:solidFill>
               </a:defRPr>
             </a:pPr>
             <a:r>
@@ -32776,7 +32731,7 @@
           </a:prstGeom>
         </p:spPr>
         <p:txBody>
-          <a:bodyPr vert="horz" wrap="square" lIns="73152" tIns="54864" rIns="73152" bIns="54864" rtlCol="0">
+          <a:bodyPr vert="horz" wrap="square" lIns="0" tIns="12700" rIns="0" bIns="0" rtlCol="0">
             <a:spAutoFit/>
           </a:bodyPr>
           <a:lstStyle/>
@@ -32788,7 +32743,6 @@
               <a:spcBef>
                 <a:spcPts val="100"/>
               </a:spcBef>
-              <a:defRPr/>
             </a:pPr>
             <a:r>
               <a:rPr sz="2300" dirty="0">
@@ -32932,7 +32886,7 @@
           </a:prstGeom>
         </p:spPr>
         <p:txBody>
-          <a:bodyPr vert="horz" wrap="square" lIns="73152" tIns="54864" rIns="73152" bIns="54864" rtlCol="0">
+          <a:bodyPr vert="horz" wrap="square" lIns="0" tIns="44450" rIns="0" bIns="0" rtlCol="0">
             <a:spAutoFit/>
           </a:bodyPr>
           <a:lstStyle/>
@@ -32944,8 +32898,9 @@
               <a:spcBef>
                 <a:spcPts val="350"/>
               </a:spcBef>
-              <a:defRPr sz="1300" b="1">
-                <a:latin typeface="Arial"/>
+              <a:defRPr sz="1700">
+                <a:solidFill/>
+                <a:latin typeface="Tahoma"/>
               </a:defRPr>
             </a:pPr>
             <a:r>
@@ -32958,8 +32913,8 @@
           </a:p>
           <a:p>
             <a:pPr>
-              <a:defRPr sz="1300">
-                <a:latin typeface="Arial"/>
+              <a:defRPr sz="1700">
+                <a:latin typeface="Tahoma"/>
               </a:defRPr>
             </a:pPr>
             <a:r>
@@ -32984,7 +32939,7 @@
           </a:prstGeom>
         </p:spPr>
         <p:txBody>
-          <a:bodyPr vert="horz" wrap="square" lIns="73152" tIns="54864" rIns="73152" bIns="54864" rtlCol="0">
+          <a:bodyPr vert="horz" wrap="square" lIns="0" tIns="44450" rIns="0" bIns="0" rtlCol="0">
             <a:spAutoFit/>
           </a:bodyPr>
           <a:lstStyle/>
@@ -32996,8 +32951,9 @@
               <a:spcBef>
                 <a:spcPts val="350"/>
               </a:spcBef>
-              <a:defRPr sz="1300" b="1">
-                <a:latin typeface="Arial"/>
+              <a:defRPr sz="1700">
+                <a:solidFill/>
+                <a:latin typeface="Tahoma"/>
               </a:defRPr>
             </a:pPr>
             <a:r>
@@ -33010,8 +32966,8 @@
           </a:p>
           <a:p>
             <a:pPr>
-              <a:defRPr sz="1300">
-                <a:latin typeface="Arial"/>
+              <a:defRPr sz="1700">
+                <a:latin typeface="Tahoma"/>
               </a:defRPr>
             </a:pPr>
             <a:r>
@@ -33036,7 +32992,7 @@
           </a:prstGeom>
         </p:spPr>
         <p:txBody>
-          <a:bodyPr vert="horz" wrap="square" lIns="73152" tIns="54864" rIns="73152" bIns="54864" rtlCol="0">
+          <a:bodyPr vert="horz" wrap="square" lIns="0" tIns="12700" rIns="0" bIns="0" rtlCol="0">
             <a:spAutoFit/>
           </a:bodyPr>
           <a:lstStyle/>
@@ -33046,10 +33002,11 @@
                 <a:spcPct val="113300"/>
               </a:lnSpc>
               <a:spcBef>
-                <a:spcPts val="300"/>
+                <a:spcPts val="100"/>
               </a:spcBef>
-              <a:defRPr sz="1150">
-                <a:latin typeface="Arial"/>
+              <a:defRPr sz="1600">
+                <a:solidFill/>
+                <a:latin typeface="Verdana"/>
               </a:defRPr>
             </a:pPr>
             <a:r>
@@ -33066,10 +33023,10 @@
                 <a:spcPct val="100000"/>
               </a:lnSpc>
               <a:spcBef>
-                <a:spcPts val="200"/>
+                <a:spcPts val="1640"/>
               </a:spcBef>
-              <a:defRPr sz="1200">
-                <a:latin typeface="Arial"/>
+              <a:defRPr sz="1600">
+                <a:latin typeface="Verdana"/>
               </a:defRPr>
             </a:pPr>
             <a:r>
@@ -33098,7 +33055,7 @@
           </a:prstGeom>
         </p:spPr>
         <p:txBody>
-          <a:bodyPr vert="horz" wrap="square" lIns="73152" tIns="54864" rIns="73152" bIns="54864" rtlCol="0">
+          <a:bodyPr vert="horz" wrap="square" lIns="0" tIns="50165" rIns="0" bIns="0" rtlCol="0">
             <a:spAutoFit/>
           </a:bodyPr>
           <a:lstStyle/>
@@ -33110,8 +33067,9 @@
               <a:spcBef>
                 <a:spcPts val="395"/>
               </a:spcBef>
-              <a:defRPr sz="1300" b="1">
-                <a:latin typeface="Arial"/>
+              <a:defRPr sz="1700">
+                <a:solidFill/>
+                <a:latin typeface="Tahoma"/>
               </a:defRPr>
             </a:pPr>
             <a:r>
@@ -33124,8 +33082,8 @@
           </a:p>
           <a:p>
             <a:pPr>
-              <a:defRPr sz="1300">
-                <a:latin typeface="Arial"/>
+              <a:defRPr sz="1700">
+                <a:latin typeface="Tahoma"/>
               </a:defRPr>
             </a:pPr>
             <a:r>
@@ -33150,7 +33108,7 @@
           </a:prstGeom>
         </p:spPr>
         <p:txBody>
-          <a:bodyPr vert="horz" wrap="square" lIns="73152" tIns="54864" rIns="73152" bIns="54864" rtlCol="0">
+          <a:bodyPr vert="horz" wrap="square" lIns="0" tIns="0" rIns="0" bIns="0" rtlCol="0">
             <a:spAutoFit/>
           </a:bodyPr>
           <a:lstStyle/>
@@ -33159,7 +33117,6 @@
               <a:lnSpc>
                 <a:spcPts val="1964"/>
               </a:lnSpc>
-              <a:defRPr/>
             </a:pPr>
             <a:r>
               <a:rPr sz="1700" b="1" spc="-10" dirty="0">
@@ -33181,7 +33138,6 @@
               <a:spcBef>
                 <a:spcPts val="285"/>
               </a:spcBef>
-              <a:defRPr/>
             </a:pPr>
             <a:r>
               <a:rPr sz="1700" b="1" spc="55" dirty="0">
@@ -33213,7 +33169,7 @@
           </a:prstGeom>
         </p:spPr>
         <p:txBody>
-          <a:bodyPr vert="horz" wrap="square" lIns="73152" tIns="54864" rIns="73152" bIns="54864" rtlCol="0">
+          <a:bodyPr vert="horz" wrap="square" lIns="0" tIns="12700" rIns="0" bIns="0" rtlCol="0">
             <a:spAutoFit/>
           </a:bodyPr>
           <a:lstStyle/>
@@ -33225,7 +33181,6 @@
               <a:spcBef>
                 <a:spcPts val="100"/>
               </a:spcBef>
-              <a:defRPr/>
             </a:pPr>
             <a:r>
               <a:rPr sz="1600" dirty="0">
@@ -33457,7 +33412,6 @@
               <a:spcBef>
                 <a:spcPts val="855"/>
               </a:spcBef>
-              <a:defRPr/>
             </a:pPr>
             <a:r>
               <a:rPr sz="1600" dirty="0">
@@ -33573,7 +33527,7 @@
           </a:prstGeom>
         </p:spPr>
         <p:txBody>
-          <a:bodyPr vert="horz" wrap="square" lIns="73152" tIns="54864" rIns="73152" bIns="54864" rtlCol="0">
+          <a:bodyPr vert="horz" wrap="square" lIns="0" tIns="12700" rIns="0" bIns="0" rtlCol="0">
             <a:spAutoFit/>
           </a:bodyPr>
           <a:lstStyle/>
@@ -33585,7 +33539,6 @@
               <a:spcBef>
                 <a:spcPts val="100"/>
               </a:spcBef>
-              <a:defRPr/>
             </a:pPr>
             <a:r>
               <a:rPr sz="1600" spc="-20" dirty="0">
@@ -33708,7 +33661,7 @@
           </a:prstGeom>
         </p:spPr>
         <p:txBody>
-          <a:bodyPr vert="horz" wrap="square" lIns="73152" tIns="54864" rIns="73152" bIns="54864" rtlCol="0">
+          <a:bodyPr vert="horz" wrap="square" lIns="0" tIns="12700" rIns="0" bIns="0" rtlCol="0">
             <a:spAutoFit/>
           </a:bodyPr>
           <a:lstStyle/>
@@ -33720,7 +33673,6 @@
               <a:spcBef>
                 <a:spcPts val="100"/>
               </a:spcBef>
-              <a:defRPr/>
             </a:pPr>
             <a:r>
               <a:rPr sz="1600" dirty="0">

</xml_diff>